<commit_message>
docs: densify Odin one-page slide with paper figures and numbers
Fill the SIGCOMM'26 Odin insight slide: left adds MoE/A2A business
context and quantified severity from the paper; right adds original
Fig.16/17 plus testbed and MoE result numbers. Footer is an industry
expert takeaway. All data and figures come from Jiang et al.

Co-authored-by: 69515164-rgb <69515164-rgb@users.noreply.github.com>
</commit_message>
<xml_diff>
--- a/docs/odin-sigcomm26.pptx
+++ b/docs/odin-sigcomm26.pptx
@@ -7,7 +7,7 @@
   <p:sldIdLst>
     <p:sldId id="256" r:id="rId7"/>
   </p:sldIdLst>
-  <p:sldSz cx="12191695" cy="6858000" type="screen4x3"/>
+  <p:sldSz cx="18288000" cy="10287000" type="screen4x3"/>
   <p:notesSz cx="6858000" cy="9144000"/>
   <p:defaultTextStyle>
     <a:defPPr>
@@ -3105,7 +3105,7 @@
         <p:spPr>
           <a:xfrm>
             <a:off x="0" y="0"/>
-            <a:ext cx="12191695" cy="6858000"/>
+            <a:ext cx="18288000" cy="10287000"/>
           </a:xfrm>
           <a:prstGeom prst="rect">
             <a:avLst/>

</xml_diff>